<commit_message>
copy: remove AI writing tells across README, deck and submission text
Applied the humanizer pass: dropped the not-X-but-Y contrasts, the
one-line closers, the staged opener and most em dashes. Submission text
is shorter and states the same facts.
</commit_message>
<xml_diff>
--- a/submission/pitch-deck.pptx
+++ b/submission/pitch-deck.pptx
@@ -3296,7 +3296,7 @@
                 </a:solidFill>
                 <a:latin typeface="Arial"/>
               </a:rPr>
-              <a:t>Stopping scam-driven transfers inside the bank's authorisation path —</a:t>
+              <a:t>Stopping scam-driven transfers inside the bank's authorisation path,</a:t>
             </a:r>
           </a:p>
           <a:p>
@@ -5062,7 +5062,7 @@
                 </a:solidFill>
                 <a:latin typeface="Arial"/>
               </a:rPr>
-              <a:t>The people who could actually stop it — the adult children — have no way in.</a:t>
+              <a:t>The adult children who could actually stop it have no way in.</a:t>
             </a:r>
           </a:p>
         </p:txBody>
@@ -6033,7 +6033,7 @@
                 </a:solidFill>
                 <a:latin typeface="Arial"/>
               </a:rPr>
-              <a:t>CONFIRM is not just a block. It recruits the one person</a:t>
+              <a:t>CONFIRM pauses the transfer and brings in the one person</a:t>
             </a:r>
           </a:p>
           <a:p>
@@ -6049,7 +6049,7 @@
                 </a:solidFill>
                 <a:latin typeface="Arial"/>
               </a:rPr>
-              <a:t>who can actually stop the scam: the family.</a:t>
+              <a:t>who can end the call: the family.</a:t>
             </a:r>
           </a:p>
         </p:txBody>
@@ -7195,7 +7195,7 @@
                 </a:solidFill>
                 <a:latin typeface="Arial"/>
               </a:rPr>
-              <a:t>The accelerator sits on-die, not behind a GPU bus — which is why</a:t>
+              <a:t>The accelerator sits on the same die as the CPU, which is why</a:t>
             </a:r>
           </a:p>
           <a:p>
@@ -10151,7 +10151,7 @@
                 </a:solidFill>
                 <a:latin typeface="Arial"/>
               </a:rPr>
-              <a:t>over time — a requirement in most regulated markets.</a:t>
+              <a:t>over time, which most regulated markets require.</a:t>
             </a:r>
           </a:p>
         </p:txBody>
@@ -10413,7 +10413,7 @@
                 </a:solidFill>
                 <a:latin typeface="Arial"/>
               </a:rPr>
-              <a:t>What this prototype is — and is not</a:t>
+              <a:t>What this prototype is and is not</a:t>
             </a:r>
           </a:p>
         </p:txBody>
@@ -10856,7 +10856,7 @@
                 </a:solidFill>
                 <a:latin typeface="Arial"/>
               </a:rPr>
-              <a:t>·  No live bank core integration — the stream is historical replay</a:t>
+              <a:t>·  No live bank core integration; the stream is historical replay</a:t>
             </a:r>
           </a:p>
         </p:txBody>

</xml_diff>

<commit_message>
feat: case replay, plus sourced elder-fraud figures
Click any row to see the transfers behind the decision. A blocked
transfer opens the six transfers that preceded it, with the amount
growth across the window, which is what the sequence model reads.

Also adds the FBI IC3 2024 figure (147,127 complaints, $4.885 billion,
up 43%) to the problem statement, the deck and the video script.
Removes the superseded scripts; VIDEO-SCRIPT.md is the one to follow.
</commit_message>
<xml_diff>
--- a/submission/pitch-deck.pptx
+++ b/submission/pitch-deck.pptx
@@ -4618,8 +4618,8 @@
         </p:nvSpPr>
         <p:spPr>
           <a:xfrm>
-            <a:off x="822960" y="3127248"/>
-            <a:ext cx="10515600" cy="566928"/>
+            <a:off x="822960" y="3017520"/>
+            <a:ext cx="10515600" cy="896112"/>
           </a:xfrm>
           <a:prstGeom prst="rect">
             <a:avLst/>
@@ -4664,8 +4664,8 @@
         </p:nvSpPr>
         <p:spPr>
           <a:xfrm>
-            <a:off x="1051560" y="3264408"/>
-            <a:ext cx="10058400" cy="320040"/>
+            <a:off x="1051560" y="3127248"/>
+            <a:ext cx="10058400" cy="310896"/>
           </a:xfrm>
           <a:prstGeom prst="rect">
             <a:avLst/>
@@ -4684,7 +4684,7 @@
               </a:lnSpc>
             </a:pPr>
             <a:r>
-              <a:rPr sz="1400" b="1" i="0">
+              <a:rPr sz="1350" b="1" i="0">
                 <a:solidFill>
                   <a:srgbClr val="DC2626"/>
                 </a:solidFill>
@@ -4697,14 +4697,53 @@
       </p:sp>
       <p:sp>
         <p:nvSpPr>
-          <p:cNvPr id="23" name="Rectangle 22"/>
+          <p:cNvPr id="23" name="TextBox 22"/>
+          <p:cNvSpPr txBox="1"/>
+          <p:nvPr/>
+        </p:nvSpPr>
+        <p:spPr>
+          <a:xfrm>
+            <a:off x="1051560" y="3474720"/>
+            <a:ext cx="10058400" cy="347472"/>
+          </a:xfrm>
+          <a:prstGeom prst="rect">
+            <a:avLst/>
+          </a:prstGeom>
+          <a:noFill/>
+        </p:spPr>
+        <p:txBody>
+          <a:bodyPr wrap="square" anchor="t">
+            <a:spAutoFit/>
+          </a:bodyPr>
+          <a:lstStyle/>
+          <a:p>
+            <a:pPr algn="l">
+              <a:lnSpc>
+                <a:spcPct val="100000"/>
+              </a:lnSpc>
+            </a:pPr>
+            <a:r>
+              <a:rPr sz="1050" b="0" i="0">
+                <a:solidFill>
+                  <a:srgbClr val="8A3A3A"/>
+                </a:solidFill>
+                <a:latin typeface="Arial"/>
+              </a:rPr>
+              <a:t>$4.885 billion reported lost by older Americans in 2024 across 147,127 complaints, up 43% on 2023.  FBI IC3, 2025</a:t>
+            </a:r>
+          </a:p>
+        </p:txBody>
+      </p:sp>
+      <p:sp>
+        <p:nvSpPr>
+          <p:cNvPr id="24" name="Rectangle 23"/>
           <p:cNvSpPr/>
           <p:nvPr/>
         </p:nvSpPr>
         <p:spPr>
           <a:xfrm>
-            <a:off x="822960" y="3977639"/>
-            <a:ext cx="3291840" cy="1691640"/>
+            <a:off x="822960" y="4133087"/>
+            <a:ext cx="3291840" cy="1645920"/>
           </a:xfrm>
           <a:prstGeom prst="rect">
             <a:avLst/>
@@ -4743,13 +4782,13 @@
       </p:sp>
       <p:sp>
         <p:nvSpPr>
-          <p:cNvPr id="24" name="TextBox 23"/>
-          <p:cNvSpPr txBox="1"/>
-          <p:nvPr/>
-        </p:nvSpPr>
-        <p:spPr>
-          <a:xfrm>
-            <a:off x="1051560" y="4160520"/>
+          <p:cNvPr id="25" name="TextBox 24"/>
+          <p:cNvSpPr txBox="1"/>
+          <p:nvPr/>
+        </p:nvSpPr>
+        <p:spPr>
+          <a:xfrm>
+            <a:off x="1051560" y="4279392"/>
             <a:ext cx="2834640" cy="365760"/>
           </a:xfrm>
           <a:prstGeom prst="rect">
@@ -4782,13 +4821,13 @@
       </p:sp>
       <p:sp>
         <p:nvSpPr>
-          <p:cNvPr id="25" name="TextBox 24"/>
-          <p:cNvSpPr txBox="1"/>
-          <p:nvPr/>
-        </p:nvSpPr>
-        <p:spPr>
-          <a:xfrm>
-            <a:off x="1051560" y="4553712"/>
+          <p:cNvPr id="26" name="TextBox 25"/>
+          <p:cNvSpPr txBox="1"/>
+          <p:nvPr/>
+        </p:nvSpPr>
+        <p:spPr>
+          <a:xfrm>
+            <a:off x="1051560" y="4663440"/>
             <a:ext cx="2834640" cy="1005840"/>
           </a:xfrm>
           <a:prstGeom prst="rect">
@@ -4821,14 +4860,14 @@
       </p:sp>
       <p:sp>
         <p:nvSpPr>
-          <p:cNvPr id="26" name="Rectangle 25"/>
+          <p:cNvPr id="27" name="Rectangle 26"/>
           <p:cNvSpPr/>
           <p:nvPr/>
         </p:nvSpPr>
         <p:spPr>
           <a:xfrm>
-            <a:off x="4389120" y="3977639"/>
-            <a:ext cx="3291840" cy="1691640"/>
+            <a:off x="4389120" y="4133087"/>
+            <a:ext cx="3291840" cy="1645920"/>
           </a:xfrm>
           <a:prstGeom prst="rect">
             <a:avLst/>
@@ -4867,13 +4906,13 @@
       </p:sp>
       <p:sp>
         <p:nvSpPr>
-          <p:cNvPr id="27" name="TextBox 26"/>
-          <p:cNvSpPr txBox="1"/>
-          <p:nvPr/>
-        </p:nvSpPr>
-        <p:spPr>
-          <a:xfrm>
-            <a:off x="4617720" y="4160520"/>
+          <p:cNvPr id="28" name="TextBox 27"/>
+          <p:cNvSpPr txBox="1"/>
+          <p:nvPr/>
+        </p:nvSpPr>
+        <p:spPr>
+          <a:xfrm>
+            <a:off x="4617720" y="4279392"/>
             <a:ext cx="2834640" cy="365760"/>
           </a:xfrm>
           <a:prstGeom prst="rect">
@@ -4906,13 +4945,13 @@
       </p:sp>
       <p:sp>
         <p:nvSpPr>
-          <p:cNvPr id="28" name="TextBox 27"/>
-          <p:cNvSpPr txBox="1"/>
-          <p:nvPr/>
-        </p:nvSpPr>
-        <p:spPr>
-          <a:xfrm>
-            <a:off x="4617720" y="4553712"/>
+          <p:cNvPr id="29" name="TextBox 28"/>
+          <p:cNvSpPr txBox="1"/>
+          <p:nvPr/>
+        </p:nvSpPr>
+        <p:spPr>
+          <a:xfrm>
+            <a:off x="4617720" y="4663440"/>
             <a:ext cx="2834640" cy="1005840"/>
           </a:xfrm>
           <a:prstGeom prst="rect">
@@ -4945,14 +4984,14 @@
       </p:sp>
       <p:sp>
         <p:nvSpPr>
-          <p:cNvPr id="29" name="Rectangle 28"/>
+          <p:cNvPr id="30" name="Rectangle 29"/>
           <p:cNvSpPr/>
           <p:nvPr/>
         </p:nvSpPr>
         <p:spPr>
           <a:xfrm>
-            <a:off x="7955279" y="3977639"/>
-            <a:ext cx="3291840" cy="1691640"/>
+            <a:off x="7955279" y="4133087"/>
+            <a:ext cx="3291840" cy="1645920"/>
           </a:xfrm>
           <a:prstGeom prst="rect">
             <a:avLst/>
@@ -4991,13 +5030,13 @@
       </p:sp>
       <p:sp>
         <p:nvSpPr>
-          <p:cNvPr id="30" name="TextBox 29"/>
-          <p:cNvSpPr txBox="1"/>
-          <p:nvPr/>
-        </p:nvSpPr>
-        <p:spPr>
-          <a:xfrm>
-            <a:off x="8183879" y="4160520"/>
+          <p:cNvPr id="31" name="TextBox 30"/>
+          <p:cNvSpPr txBox="1"/>
+          <p:nvPr/>
+        </p:nvSpPr>
+        <p:spPr>
+          <a:xfrm>
+            <a:off x="8183879" y="4279392"/>
             <a:ext cx="2834640" cy="365760"/>
           </a:xfrm>
           <a:prstGeom prst="rect">
@@ -5030,13 +5069,13 @@
       </p:sp>
       <p:sp>
         <p:nvSpPr>
-          <p:cNvPr id="31" name="TextBox 30"/>
-          <p:cNvSpPr txBox="1"/>
-          <p:nvPr/>
-        </p:nvSpPr>
-        <p:spPr>
-          <a:xfrm>
-            <a:off x="8183879" y="4553712"/>
+          <p:cNvPr id="32" name="TextBox 31"/>
+          <p:cNvSpPr txBox="1"/>
+          <p:nvPr/>
+        </p:nvSpPr>
+        <p:spPr>
+          <a:xfrm>
+            <a:off x="8183879" y="4663440"/>
             <a:ext cx="2834640" cy="1005840"/>
           </a:xfrm>
           <a:prstGeom prst="rect">
@@ -5069,7 +5108,7 @@
       </p:sp>
       <p:sp>
         <p:nvSpPr>
-          <p:cNvPr id="32" name="TextBox 31"/>
+          <p:cNvPr id="33" name="TextBox 32"/>
           <p:cNvSpPr txBox="1"/>
           <p:nvPr/>
         </p:nvSpPr>
@@ -5108,7 +5147,7 @@
       </p:sp>
       <p:sp>
         <p:nvSpPr>
-          <p:cNvPr id="33" name="TextBox 32"/>
+          <p:cNvPr id="34" name="TextBox 33"/>
           <p:cNvSpPr txBox="1"/>
           <p:nvPr/>
         </p:nvSpPr>

</xml_diff>

<commit_message>
fix(deck): three layout defects found by rendering every page
Rendered all nine pages and found what only a visual check shows:

- p2: the third card title wrapped to two lines and collided with its
  body text. Shortened to one line.
- p4: the architecture image overflowed the slide by an inch and its
  caption sat on top of the diagram. The image also repeated the slide
  title and still said 35 ms. Regenerated without the duplicate title,
  corrected to 22 ms, and placed by height so it clears the footer.
- p5: the console caption overlapped the footer. Removed it and enlarged
  the screenshot.
</commit_message>
<xml_diff>
--- a/submission/pitch-deck.pptx
+++ b/submission/pitch-deck.pptx
@@ -4938,7 +4938,7 @@
                 </a:solidFill>
                 <a:latin typeface="Arial"/>
               </a:rPr>
-              <a:t>Existing systems target card fraud</a:t>
+              <a:t>Built for card fraud</a:t>
             </a:r>
           </a:p>
         </p:txBody>
@@ -6465,8 +6465,8 @@
         </p:blipFill>
         <p:spPr>
           <a:xfrm>
-            <a:off x="502920" y="1481328"/>
-            <a:ext cx="11201400" cy="6343650"/>
+            <a:off x="1042415" y="1417320"/>
+            <a:ext cx="10002800" cy="4892040"/>
           </a:xfrm>
           <a:prstGeom prst="rect">
             <a:avLst/>
@@ -6476,45 +6476,6 @@
       <p:sp>
         <p:nvSpPr>
           <p:cNvPr id="7" name="TextBox 6"/>
-          <p:cNvSpPr txBox="1"/>
-          <p:nvPr/>
-        </p:nvSpPr>
-        <p:spPr>
-          <a:xfrm>
-            <a:off x="822960" y="6144768"/>
-            <a:ext cx="10515600" cy="274320"/>
-          </a:xfrm>
-          <a:prstGeom prst="rect">
-            <a:avLst/>
-          </a:prstGeom>
-          <a:noFill/>
-        </p:spPr>
-        <p:txBody>
-          <a:bodyPr wrap="square" anchor="t">
-            <a:spAutoFit/>
-          </a:bodyPr>
-          <a:lstStyle/>
-          <a:p>
-            <a:pPr algn="l">
-              <a:lnSpc>
-                <a:spcPct val="100000"/>
-              </a:lnSpc>
-            </a:pPr>
-            <a:r>
-              <a:rPr sz="1000" b="0" i="1">
-                <a:solidFill>
-                  <a:srgbClr val="5C6B80"/>
-                </a:solidFill>
-                <a:latin typeface="Arial"/>
-              </a:rPr>
-              <a:t>Decision and explanation are decoupled: the decision returns in ~22 ms, while IBM Granite explains asynchronously.</a:t>
-            </a:r>
-          </a:p>
-        </p:txBody>
-      </p:sp>
-      <p:sp>
-        <p:nvSpPr>
-          <p:cNvPr id="8" name="TextBox 7"/>
           <p:cNvSpPr txBox="1"/>
           <p:nvPr/>
         </p:nvSpPr>
@@ -6553,7 +6514,7 @@
       </p:sp>
       <p:sp>
         <p:nvSpPr>
-          <p:cNvPr id="9" name="TextBox 8"/>
+          <p:cNvPr id="8" name="TextBox 7"/>
           <p:cNvSpPr txBox="1"/>
           <p:nvPr/>
         </p:nvSpPr>
@@ -6790,8 +6751,8 @@
         </p:blipFill>
         <p:spPr>
           <a:xfrm>
-            <a:off x="1234440" y="1371600"/>
-            <a:ext cx="9022080" cy="5074920"/>
+            <a:off x="1664208" y="1325880"/>
+            <a:ext cx="8859520" cy="4983480"/>
           </a:xfrm>
           <a:prstGeom prst="rect">
             <a:avLst/>
@@ -6801,45 +6762,6 @@
       <p:sp>
         <p:nvSpPr>
           <p:cNvPr id="7" name="TextBox 6"/>
-          <p:cNvSpPr txBox="1"/>
-          <p:nvPr/>
-        </p:nvSpPr>
-        <p:spPr>
-          <a:xfrm>
-            <a:off x="822960" y="6510528"/>
-            <a:ext cx="10515600" cy="274320"/>
-          </a:xfrm>
-          <a:prstGeom prst="rect">
-            <a:avLst/>
-          </a:prstGeom>
-          <a:noFill/>
-        </p:spPr>
-        <p:txBody>
-          <a:bodyPr wrap="square" anchor="t">
-            <a:spAutoFit/>
-          </a:bodyPr>
-          <a:lstStyle/>
-          <a:p>
-            <a:pPr algn="l">
-              <a:lnSpc>
-                <a:spcPct val="100000"/>
-              </a:lnSpc>
-            </a:pPr>
-            <a:r>
-              <a:rPr sz="1000" b="0" i="1">
-                <a:solidFill>
-                  <a:srgbClr val="5C6B80"/>
-                </a:solidFill>
-                <a:latin typeface="Arial"/>
-              </a:rPr>
-              <a:t>Every row is a live decision. Right lane: the plain-language message the holder sees, and the alert the linked relative receives.</a:t>
-            </a:r>
-          </a:p>
-        </p:txBody>
-      </p:sp>
-      <p:sp>
-        <p:nvSpPr>
-          <p:cNvPr id="8" name="TextBox 7"/>
           <p:cNvSpPr txBox="1"/>
           <p:nvPr/>
         </p:nvSpPr>
@@ -6878,7 +6800,7 @@
       </p:sp>
       <p:sp>
         <p:nvSpPr>
-          <p:cNvPr id="9" name="TextBox 8"/>
+          <p:cNvPr id="8" name="TextBox 7"/>
           <p:cNvSpPr txBox="1"/>
           <p:nvPr/>
         </p:nvSpPr>

</xml_diff>